<commit_message>
Fix slides git P2
</commit_message>
<xml_diff>
--- a/git_course/2_collaboration/git_collaboration.pptx
+++ b/git_course/2_collaboration/git_collaboration.pptx
@@ -1856,18 +1856,7 @@
               <a:tabLst/>
               <a:defRPr/>
             </a:pPr>
-            <a:r>
-              <a:rPr lang="nl-NL" dirty="0"/>
-              <a:t>Demo: GH: </a:t>
-            </a:r>
-            <a:r>
-              <a:rPr lang="nl-NL" dirty="0" err="1"/>
-              <a:t>create</a:t>
-            </a:r>
-            <a:r>
-              <a:rPr lang="nl-NL" dirty="0"/>
-              <a:t> workflow.</a:t>
-            </a:r>
+            <a:endParaRPr lang="nl-NL" dirty="0"/>
           </a:p>
         </p:txBody>
       </p:sp>
@@ -2212,7 +2201,18 @@
               <a:tabLst/>
               <a:defRPr/>
             </a:pPr>
-            <a:endParaRPr lang="nl-NL" dirty="0"/>
+            <a:r>
+              <a:rPr lang="nl-NL" dirty="0"/>
+              <a:t>Demo: GH: </a:t>
+            </a:r>
+            <a:r>
+              <a:rPr lang="nl-NL" dirty="0" err="1"/>
+              <a:t>create</a:t>
+            </a:r>
+            <a:r>
+              <a:rPr lang="nl-NL" dirty="0"/>
+              <a:t> workflow.</a:t>
+            </a:r>
           </a:p>
         </p:txBody>
       </p:sp>
@@ -4913,18 +4913,7 @@
               <a:tabLst/>
               <a:defRPr/>
             </a:pPr>
-            <a:r>
-              <a:rPr lang="nl-NL" dirty="0"/>
-              <a:t>Demo: </a:t>
-            </a:r>
-            <a:r>
-              <a:rPr lang="nl-NL" dirty="0" err="1"/>
-              <a:t>branch</a:t>
-            </a:r>
-            <a:r>
-              <a:rPr lang="nl-NL" dirty="0"/>
-              <a:t> tracking</a:t>
-            </a:r>
+            <a:endParaRPr lang="nl-NL" dirty="0"/>
           </a:p>
         </p:txBody>
       </p:sp>
@@ -5025,7 +5014,18 @@
               <a:tabLst/>
               <a:defRPr/>
             </a:pPr>
-            <a:endParaRPr lang="nl-NL" dirty="0"/>
+            <a:r>
+              <a:rPr lang="nl-NL" dirty="0"/>
+              <a:t>Demo: </a:t>
+            </a:r>
+            <a:r>
+              <a:rPr lang="nl-NL" dirty="0" err="1"/>
+              <a:t>branch</a:t>
+            </a:r>
+            <a:r>
+              <a:rPr lang="nl-NL" dirty="0"/>
+              <a:t> tracking</a:t>
+            </a:r>
           </a:p>
         </p:txBody>
       </p:sp>
@@ -9402,7 +9402,7 @@
             </a:pPr>
             <a:r>
               <a:rPr lang="nl-NL" sz="1600" dirty="0"/>
-              <a:t>Maakt directory aan met de naam van het repository.</a:t>
+              <a:t>Maakt werk directory aan met de naam van het repository.</a:t>
             </a:r>
           </a:p>
           <a:p>
@@ -11557,7 +11557,7 @@
                 <a:latin typeface="Courier New" panose="02070309020205020404" pitchFamily="49" charset="0"/>
                 <a:cs typeface="Courier New" panose="02070309020205020404" pitchFamily="49" charset="0"/>
               </a:rPr>
-              <a:t> https://github.com/LFKoning/pig-latin</a:t>
+              <a:t> https://github.com/You/pig-latin</a:t>
             </a:r>
           </a:p>
           <a:p>
@@ -22082,7 +22082,7 @@
               <a:rPr lang="nl-NL" sz="1800" dirty="0">
                 <a:cs typeface="Courier New" panose="02070309020205020404" pitchFamily="49" charset="0"/>
               </a:rPr>
-              <a:t>Voor welke branches de pipeline draait.</a:t>
+              <a:t>Voor welke branches de Workflow draait.</a:t>
             </a:r>
           </a:p>
           <a:p>
@@ -22933,6 +22933,42 @@
                 <a:cs typeface="Courier New" panose="02070309020205020404" pitchFamily="49" charset="0"/>
               </a:rPr>
               <a:t>Klik op een Workflow run voor logging.</a:t>
+            </a:r>
+          </a:p>
+        </p:txBody>
+      </p:sp>
+      <p:sp>
+        <p:nvSpPr>
+          <p:cNvPr id="3" name="TextBox 2">
+            <a:extLst>
+              <a:ext uri="{FF2B5EF4-FFF2-40B4-BE49-F238E27FC236}">
+                <a16:creationId xmlns:a16="http://schemas.microsoft.com/office/drawing/2014/main" id="{D48E1496-6026-7555-F17E-08164D7C81F6}"/>
+              </a:ext>
+            </a:extLst>
+          </p:cNvPr>
+          <p:cNvSpPr txBox="1"/>
+          <p:nvPr/>
+        </p:nvSpPr>
+        <p:spPr>
+          <a:xfrm>
+            <a:off x="9619967" y="6471982"/>
+            <a:ext cx="2499246" cy="307777"/>
+          </a:xfrm>
+          <a:prstGeom prst="rect">
+            <a:avLst/>
+          </a:prstGeom>
+          <a:noFill/>
+        </p:spPr>
+        <p:txBody>
+          <a:bodyPr wrap="square">
+            <a:spAutoFit/>
+          </a:bodyPr>
+          <a:lstStyle/>
+          <a:p>
+            <a:pPr algn="r"/>
+            <a:r>
+              <a:rPr lang="en-US" sz="1400" dirty="0"/>
+              <a:t>D: create workflow.</a:t>
             </a:r>
           </a:p>
         </p:txBody>
@@ -39259,6 +39295,7 @@
             </a:extLst>
           </p:cNvPr>
           <p:cNvCxnSpPr>
+            <a:cxnSpLocks/>
             <a:stCxn id="9" idx="6"/>
             <a:endCxn id="6" idx="1"/>
           </p:cNvCxnSpPr>
@@ -39268,48 +39305,6 @@
           <a:xfrm flipV="1">
             <a:off x="2283236" y="5321354"/>
             <a:ext cx="989255" cy="1"/>
-          </a:xfrm>
-          <a:prstGeom prst="straightConnector1">
-            <a:avLst/>
-          </a:prstGeom>
-          <a:ln>
-            <a:headEnd type="triangle"/>
-            <a:tailEnd type="triangle"/>
-          </a:ln>
-        </p:spPr>
-        <p:style>
-          <a:lnRef idx="3">
-            <a:schemeClr val="dk1"/>
-          </a:lnRef>
-          <a:fillRef idx="0">
-            <a:schemeClr val="dk1"/>
-          </a:fillRef>
-          <a:effectRef idx="2">
-            <a:schemeClr val="dk1"/>
-          </a:effectRef>
-          <a:fontRef idx="minor">
-            <a:schemeClr val="tx1"/>
-          </a:fontRef>
-        </p:style>
-      </p:cxnSp>
-      <p:cxnSp>
-        <p:nvCxnSpPr>
-          <p:cNvPr id="12" name="Straight Arrow Connector 11">
-            <a:extLst>
-              <a:ext uri="{FF2B5EF4-FFF2-40B4-BE49-F238E27FC236}">
-                <a16:creationId xmlns:a16="http://schemas.microsoft.com/office/drawing/2014/main" id="{8196E141-97AA-ED45-AB35-DEA5942C0A37}"/>
-              </a:ext>
-            </a:extLst>
-          </p:cNvPr>
-          <p:cNvCxnSpPr>
-            <a:cxnSpLocks/>
-          </p:cNvCxnSpPr>
-          <p:nvPr/>
-        </p:nvCxnSpPr>
-        <p:spPr>
-          <a:xfrm rot="5400000" flipH="1">
-            <a:off x="2777863" y="5025302"/>
-            <a:ext cx="1" cy="966651"/>
           </a:xfrm>
           <a:prstGeom prst="straightConnector1">
             <a:avLst/>

</xml_diff>